<commit_message>
Remove ward dependencies in UI and backend, substitute with address
</commit_message>
<xml_diff>
--- a/CivicPulse-BRICS_Pitch_Deck_Light.pptx
+++ b/CivicPulse-BRICS_Pitch_Deck_Light.pptx
@@ -138,8 +138,8 @@
 <pc:chgInfo xmlns:a="http://schemas.openxmlformats.org/drawingml/2006/main" xmlns:r="http://schemas.openxmlformats.org/officeDocument/2006/relationships" xmlns:ac="http://schemas.microsoft.com/office/drawing/2013/main/command" xmlns:pc="http://schemas.microsoft.com/office/powerpoint/2013/main/command">
   <pc:docChgLst>
     <pc:chgData name="Paras Singh" userId="58a414ff1ad2c8c5" providerId="LiveId" clId="{DFD62CD7-C182-471F-AA51-D706BC598118}"/>
-    <pc:docChg chg="modSld">
-      <pc:chgData name="Paras Singh" userId="58a414ff1ad2c8c5" providerId="LiveId" clId="{DFD62CD7-C182-471F-AA51-D706BC598118}" dt="2026-09-26T12:22:24.300" v="185" actId="1076"/>
+    <pc:docChg chg="custSel modSld">
+      <pc:chgData name="Paras Singh" userId="58a414ff1ad2c8c5" providerId="LiveId" clId="{DFD62CD7-C182-471F-AA51-D706BC598118}" dt="2026-09-26T12:51:15.716" v="264" actId="20577"/>
       <pc:docMkLst>
         <pc:docMk/>
       </pc:docMkLst>
@@ -230,11 +230,19 @@
         </pc:spChg>
       </pc:sldChg>
       <pc:sldChg chg="addSp modSp mod">
-        <pc:chgData name="Paras Singh" userId="58a414ff1ad2c8c5" providerId="LiveId" clId="{DFD62CD7-C182-471F-AA51-D706BC598118}" dt="2026-09-26T12:18:36.409" v="168" actId="1076"/>
+        <pc:chgData name="Paras Singh" userId="58a414ff1ad2c8c5" providerId="LiveId" clId="{DFD62CD7-C182-471F-AA51-D706BC598118}" dt="2026-09-26T12:44:00.232" v="254" actId="1076"/>
         <pc:sldMkLst>
           <pc:docMk/>
           <pc:sldMk cId="0" sldId="258"/>
         </pc:sldMkLst>
+        <pc:spChg chg="mod">
+          <ac:chgData name="Paras Singh" userId="58a414ff1ad2c8c5" providerId="LiveId" clId="{DFD62CD7-C182-471F-AA51-D706BC598118}" dt="2026-09-26T12:42:38.844" v="243" actId="14100"/>
+          <ac:spMkLst>
+            <pc:docMk/>
+            <pc:sldMk cId="0" sldId="258"/>
+            <ac:spMk id="6" creationId="{00000000-0000-0000-0000-000000000000}"/>
+          </ac:spMkLst>
+        </pc:spChg>
         <pc:spChg chg="mod">
           <ac:chgData name="Paras Singh" userId="58a414ff1ad2c8c5" providerId="LiveId" clId="{DFD62CD7-C182-471F-AA51-D706BC598118}" dt="2026-09-26T11:55:57.065" v="20" actId="14100"/>
           <ac:spMkLst>
@@ -244,11 +252,27 @@
           </ac:spMkLst>
         </pc:spChg>
         <pc:spChg chg="mod">
+          <ac:chgData name="Paras Singh" userId="58a414ff1ad2c8c5" providerId="LiveId" clId="{DFD62CD7-C182-471F-AA51-D706BC598118}" dt="2026-09-26T12:42:45.504" v="244" actId="14100"/>
+          <ac:spMkLst>
+            <pc:docMk/>
+            <pc:sldMk cId="0" sldId="258"/>
+            <ac:spMk id="9" creationId="{00000000-0000-0000-0000-000000000000}"/>
+          </ac:spMkLst>
+        </pc:spChg>
+        <pc:spChg chg="mod">
           <ac:chgData name="Paras Singh" userId="58a414ff1ad2c8c5" providerId="LiveId" clId="{DFD62CD7-C182-471F-AA51-D706BC598118}" dt="2026-09-26T11:56:15.486" v="24" actId="14100"/>
           <ac:spMkLst>
             <pc:docMk/>
             <pc:sldMk cId="0" sldId="258"/>
             <ac:spMk id="10" creationId="{00000000-0000-0000-0000-000000000000}"/>
+          </ac:spMkLst>
+        </pc:spChg>
+        <pc:spChg chg="mod">
+          <ac:chgData name="Paras Singh" userId="58a414ff1ad2c8c5" providerId="LiveId" clId="{DFD62CD7-C182-471F-AA51-D706BC598118}" dt="2026-09-26T12:42:53.244" v="245" actId="14100"/>
+          <ac:spMkLst>
+            <pc:docMk/>
+            <pc:sldMk cId="0" sldId="258"/>
+            <ac:spMk id="12" creationId="{00000000-0000-0000-0000-000000000000}"/>
           </ac:spMkLst>
         </pc:spChg>
         <pc:spChg chg="mod">
@@ -283,19 +307,51 @@
             <ac:picMk id="18" creationId="{6174CD23-22F3-57A6-3035-874EF8CA823A}"/>
           </ac:picMkLst>
         </pc:picChg>
+        <pc:picChg chg="add mod">
+          <ac:chgData name="Paras Singh" userId="58a414ff1ad2c8c5" providerId="LiveId" clId="{DFD62CD7-C182-471F-AA51-D706BC598118}" dt="2026-09-26T12:43:54.209" v="253" actId="1076"/>
+          <ac:picMkLst>
+            <pc:docMk/>
+            <pc:sldMk cId="0" sldId="258"/>
+            <ac:picMk id="20" creationId="{1B17D39B-7750-269C-E354-AFDC45A7CC16}"/>
+          </ac:picMkLst>
+        </pc:picChg>
+        <pc:picChg chg="add mod">
+          <ac:chgData name="Paras Singh" userId="58a414ff1ad2c8c5" providerId="LiveId" clId="{DFD62CD7-C182-471F-AA51-D706BC598118}" dt="2026-09-26T12:44:00.232" v="254" actId="1076"/>
+          <ac:picMkLst>
+            <pc:docMk/>
+            <pc:sldMk cId="0" sldId="258"/>
+            <ac:picMk id="22" creationId="{F07E5F78-299F-3E21-EA01-CDFB361241F5}"/>
+          </ac:picMkLst>
+        </pc:picChg>
       </pc:sldChg>
-      <pc:sldChg chg="addSp modSp mod">
-        <pc:chgData name="Paras Singh" userId="58a414ff1ad2c8c5" providerId="LiveId" clId="{DFD62CD7-C182-471F-AA51-D706BC598118}" dt="2026-09-26T12:22:24.300" v="185" actId="1076"/>
+      <pc:sldChg chg="addSp delSp modSp mod">
+        <pc:chgData name="Paras Singh" userId="58a414ff1ad2c8c5" providerId="LiveId" clId="{DFD62CD7-C182-471F-AA51-D706BC598118}" dt="2026-09-26T12:44:21.048" v="256" actId="14100"/>
         <pc:sldMkLst>
           <pc:docMk/>
           <pc:sldMk cId="0" sldId="259"/>
         </pc:sldMkLst>
+        <pc:spChg chg="mod">
+          <ac:chgData name="Paras Singh" userId="58a414ff1ad2c8c5" providerId="LiveId" clId="{DFD62CD7-C182-471F-AA51-D706BC598118}" dt="2026-09-26T12:40:25.135" v="230" actId="14100"/>
+          <ac:spMkLst>
+            <pc:docMk/>
+            <pc:sldMk cId="0" sldId="259"/>
+            <ac:spMk id="6" creationId="{00000000-0000-0000-0000-000000000000}"/>
+          </ac:spMkLst>
+        </pc:spChg>
         <pc:spChg chg="mod">
           <ac:chgData name="Paras Singh" userId="58a414ff1ad2c8c5" providerId="LiveId" clId="{DFD62CD7-C182-471F-AA51-D706BC598118}" dt="2026-09-26T11:56:58.335" v="34" actId="14100"/>
           <ac:spMkLst>
             <pc:docMk/>
             <pc:sldMk cId="0" sldId="259"/>
             <ac:spMk id="7" creationId="{00000000-0000-0000-0000-000000000000}"/>
+          </ac:spMkLst>
+        </pc:spChg>
+        <pc:spChg chg="mod">
+          <ac:chgData name="Paras Singh" userId="58a414ff1ad2c8c5" providerId="LiveId" clId="{DFD62CD7-C182-471F-AA51-D706BC598118}" dt="2026-09-26T12:34:36.580" v="186" actId="14100"/>
+          <ac:spMkLst>
+            <pc:docMk/>
+            <pc:sldMk cId="0" sldId="259"/>
+            <ac:spMk id="8" creationId="{00000000-0000-0000-0000-000000000000}"/>
           </ac:spMkLst>
         </pc:spChg>
         <pc:spChg chg="mod">
@@ -328,6 +384,46 @@
             <pc:docMk/>
             <pc:sldMk cId="0" sldId="259"/>
             <ac:picMk id="15" creationId="{376A08B0-7B6E-E0E6-CD3C-375F9441047E}"/>
+          </ac:picMkLst>
+        </pc:picChg>
+        <pc:picChg chg="add del mod modCrop">
+          <ac:chgData name="Paras Singh" userId="58a414ff1ad2c8c5" providerId="LiveId" clId="{DFD62CD7-C182-471F-AA51-D706BC598118}" dt="2026-09-26T12:37:07.050" v="206" actId="478"/>
+          <ac:picMkLst>
+            <pc:docMk/>
+            <pc:sldMk cId="0" sldId="259"/>
+            <ac:picMk id="17" creationId="{FC02B1CA-3A5C-4F11-AEE0-1A233140B8B1}"/>
+          </ac:picMkLst>
+        </pc:picChg>
+        <pc:picChg chg="add del mod modCrop">
+          <ac:chgData name="Paras Singh" userId="58a414ff1ad2c8c5" providerId="LiveId" clId="{DFD62CD7-C182-471F-AA51-D706BC598118}" dt="2026-09-26T12:38:49.819" v="217" actId="478"/>
+          <ac:picMkLst>
+            <pc:docMk/>
+            <pc:sldMk cId="0" sldId="259"/>
+            <ac:picMk id="19" creationId="{873C1B2C-BD64-B3F9-3B47-1937BF4E0FA8}"/>
+          </ac:picMkLst>
+        </pc:picChg>
+        <pc:picChg chg="add del mod modCrop">
+          <ac:chgData name="Paras Singh" userId="58a414ff1ad2c8c5" providerId="LiveId" clId="{DFD62CD7-C182-471F-AA51-D706BC598118}" dt="2026-09-26T12:40:34.542" v="232" actId="478"/>
+          <ac:picMkLst>
+            <pc:docMk/>
+            <pc:sldMk cId="0" sldId="259"/>
+            <ac:picMk id="21" creationId="{3B7FC725-B625-04CC-60AB-CCDA8FD9D4E1}"/>
+          </ac:picMkLst>
+        </pc:picChg>
+        <pc:picChg chg="add mod modCrop">
+          <ac:chgData name="Paras Singh" userId="58a414ff1ad2c8c5" providerId="LiveId" clId="{DFD62CD7-C182-471F-AA51-D706BC598118}" dt="2026-09-26T12:44:17.281" v="255" actId="14100"/>
+          <ac:picMkLst>
+            <pc:docMk/>
+            <pc:sldMk cId="0" sldId="259"/>
+            <ac:picMk id="23" creationId="{C5D5B4ED-6C6F-6E60-0600-CA68D862D97E}"/>
+          </ac:picMkLst>
+        </pc:picChg>
+        <pc:picChg chg="add mod modCrop">
+          <ac:chgData name="Paras Singh" userId="58a414ff1ad2c8c5" providerId="LiveId" clId="{DFD62CD7-C182-471F-AA51-D706BC598118}" dt="2026-09-26T12:44:21.048" v="256" actId="14100"/>
+          <ac:picMkLst>
+            <pc:docMk/>
+            <pc:sldMk cId="0" sldId="259"/>
+            <ac:picMk id="25" creationId="{119F8A59-A6FD-80A0-2348-2EF6B093950A}"/>
           </ac:picMkLst>
         </pc:picChg>
       </pc:sldChg>
@@ -378,7 +474,7 @@
         </pc:spChg>
       </pc:sldChg>
       <pc:sldChg chg="modSp mod">
-        <pc:chgData name="Paras Singh" userId="58a414ff1ad2c8c5" providerId="LiveId" clId="{DFD62CD7-C182-471F-AA51-D706BC598118}" dt="2026-09-26T11:58:55.840" v="58" actId="14100"/>
+        <pc:chgData name="Paras Singh" userId="58a414ff1ad2c8c5" providerId="LiveId" clId="{DFD62CD7-C182-471F-AA51-D706BC598118}" dt="2026-09-26T12:51:15.716" v="264" actId="20577"/>
         <pc:sldMkLst>
           <pc:docMk/>
           <pc:sldMk cId="0" sldId="262"/>
@@ -391,15 +487,23 @@
             <ac:spMk id="7" creationId="{00000000-0000-0000-0000-000000000000}"/>
           </ac:spMkLst>
         </pc:spChg>
+        <pc:spChg chg="mod">
+          <ac:chgData name="Paras Singh" userId="58a414ff1ad2c8c5" providerId="LiveId" clId="{DFD62CD7-C182-471F-AA51-D706BC598118}" dt="2026-09-26T12:51:15.716" v="264" actId="20577"/>
+          <ac:spMkLst>
+            <pc:docMk/>
+            <pc:sldMk cId="0" sldId="262"/>
+            <ac:spMk id="8" creationId="{00000000-0000-0000-0000-000000000000}"/>
+          </ac:spMkLst>
+        </pc:spChg>
       </pc:sldChg>
       <pc:sldChg chg="addSp delSp modSp mod">
-        <pc:chgData name="Paras Singh" userId="58a414ff1ad2c8c5" providerId="LiveId" clId="{DFD62CD7-C182-471F-AA51-D706BC598118}" dt="2026-09-26T12:03:37.385" v="98" actId="1076"/>
+        <pc:chgData name="Paras Singh" userId="58a414ff1ad2c8c5" providerId="LiveId" clId="{DFD62CD7-C182-471F-AA51-D706BC598118}" dt="2026-09-26T12:45:27.423" v="262" actId="14100"/>
         <pc:sldMkLst>
           <pc:docMk/>
           <pc:sldMk cId="0" sldId="263"/>
         </pc:sldMkLst>
         <pc:spChg chg="mod">
-          <ac:chgData name="Paras Singh" userId="58a414ff1ad2c8c5" providerId="LiveId" clId="{DFD62CD7-C182-471F-AA51-D706BC598118}" dt="2026-09-26T12:03:26.497" v="97" actId="14100"/>
+          <ac:chgData name="Paras Singh" userId="58a414ff1ad2c8c5" providerId="LiveId" clId="{DFD62CD7-C182-471F-AA51-D706BC598118}" dt="2026-09-26T12:45:27.423" v="262" actId="14100"/>
           <ac:spMkLst>
             <pc:docMk/>
             <pc:sldMk cId="0" sldId="263"/>
@@ -424,13 +528,13 @@
         </pc:picChg>
       </pc:sldChg>
       <pc:sldChg chg="addSp delSp modSp mod">
-        <pc:chgData name="Paras Singh" userId="58a414ff1ad2c8c5" providerId="LiveId" clId="{DFD62CD7-C182-471F-AA51-D706BC598118}" dt="2026-09-26T12:06:37.244" v="114"/>
+        <pc:chgData name="Paras Singh" userId="58a414ff1ad2c8c5" providerId="LiveId" clId="{DFD62CD7-C182-471F-AA51-D706BC598118}" dt="2026-09-26T12:45:16.337" v="260" actId="14100"/>
         <pc:sldMkLst>
           <pc:docMk/>
           <pc:sldMk cId="0" sldId="264"/>
         </pc:sldMkLst>
         <pc:spChg chg="mod">
-          <ac:chgData name="Paras Singh" userId="58a414ff1ad2c8c5" providerId="LiveId" clId="{DFD62CD7-C182-471F-AA51-D706BC598118}" dt="2026-09-26T12:06:35.746" v="112" actId="14100"/>
+          <ac:chgData name="Paras Singh" userId="58a414ff1ad2c8c5" providerId="LiveId" clId="{DFD62CD7-C182-471F-AA51-D706BC598118}" dt="2026-09-26T12:45:16.337" v="260" actId="14100"/>
           <ac:spMkLst>
             <pc:docMk/>
             <pc:sldMk cId="0" sldId="264"/>
@@ -455,13 +559,13 @@
         </pc:picChg>
       </pc:sldChg>
       <pc:sldChg chg="addSp delSp modSp mod">
-        <pc:chgData name="Paras Singh" userId="58a414ff1ad2c8c5" providerId="LiveId" clId="{DFD62CD7-C182-471F-AA51-D706BC598118}" dt="2026-09-26T12:08:33.122" v="128" actId="1076"/>
+        <pc:chgData name="Paras Singh" userId="58a414ff1ad2c8c5" providerId="LiveId" clId="{DFD62CD7-C182-471F-AA51-D706BC598118}" dt="2026-09-26T12:44:59.746" v="258" actId="14100"/>
         <pc:sldMkLst>
           <pc:docMk/>
           <pc:sldMk cId="0" sldId="265"/>
         </pc:sldMkLst>
         <pc:spChg chg="mod">
-          <ac:chgData name="Paras Singh" userId="58a414ff1ad2c8c5" providerId="LiveId" clId="{DFD62CD7-C182-471F-AA51-D706BC598118}" dt="2026-09-26T12:08:26.788" v="127" actId="14100"/>
+          <ac:chgData name="Paras Singh" userId="58a414ff1ad2c8c5" providerId="LiveId" clId="{DFD62CD7-C182-471F-AA51-D706BC598118}" dt="2026-09-26T12:44:59.746" v="258" actId="14100"/>
           <ac:spMkLst>
             <pc:docMk/>
             <pc:sldMk cId="0" sldId="265"/>
@@ -3938,8 +4042,8 @@
         </p:nvSpPr>
         <p:spPr>
           <a:xfrm>
-            <a:off x="2616200" y="1600200"/>
-            <a:ext cx="6985000" cy="4640580"/>
+            <a:off x="2387600" y="1463040"/>
+            <a:ext cx="7396480" cy="4917440"/>
           </a:xfrm>
           <a:prstGeom prst="roundRect">
             <a:avLst/>
@@ -6147,7 +6251,7 @@
         <p:spPr>
           <a:xfrm>
             <a:off x="914400" y="2286000"/>
-            <a:ext cx="3200400" cy="3200400"/>
+            <a:ext cx="3200400" cy="3698240"/>
           </a:xfrm>
           <a:prstGeom prst="roundRect">
             <a:avLst/>
@@ -6259,6 +6363,7 @@
               </a:defRPr>
             </a:pPr>
             <a:r>
+              <a:rPr dirty="0"/>
               <a:t>1. Multimodal Citizen App</a:t>
             </a:r>
           </a:p>
@@ -6275,6 +6380,7 @@
               </a:defRPr>
             </a:pPr>
             <a:r>
+              <a:rPr dirty="0"/>
               <a:t>Citizens can report issues using photos, voice notes, and GPS. Community demands can be upvoted for participatory budgeting.</a:t>
             </a:r>
           </a:p>
@@ -6289,7 +6395,7 @@
         <p:spPr>
           <a:xfrm>
             <a:off x="4480560" y="2286000"/>
-            <a:ext cx="3200400" cy="3200400"/>
+            <a:ext cx="3200400" cy="3698240"/>
           </a:xfrm>
           <a:prstGeom prst="roundRect">
             <a:avLst/>
@@ -6431,7 +6537,7 @@
         <p:spPr>
           <a:xfrm>
             <a:off x="8046720" y="2286000"/>
-            <a:ext cx="3200400" cy="3200400"/>
+            <a:ext cx="3200400" cy="3698240"/>
           </a:xfrm>
           <a:prstGeom prst="roundRect">
             <a:avLst/>
@@ -6618,6 +6724,68 @@
           <a:xfrm>
             <a:off x="1138478" y="3863304"/>
             <a:ext cx="2878346" cy="1798779"/>
+          </a:xfrm>
+          <a:prstGeom prst="rect">
+            <a:avLst/>
+          </a:prstGeom>
+        </p:spPr>
+      </p:pic>
+      <p:pic>
+        <p:nvPicPr>
+          <p:cNvPr id="20" name="Picture 19">
+            <a:extLst>
+              <a:ext uri="{FF2B5EF4-FFF2-40B4-BE49-F238E27FC236}">
+                <a16:creationId xmlns:a16="http://schemas.microsoft.com/office/drawing/2014/main" id="{1B17D39B-7750-269C-E354-AFDC45A7CC16}"/>
+              </a:ext>
+            </a:extLst>
+          </p:cNvPr>
+          <p:cNvPicPr>
+            <a:picLocks noChangeAspect="1"/>
+          </p:cNvPicPr>
+          <p:nvPr/>
+        </p:nvPicPr>
+        <p:blipFill>
+          <a:blip r:embed="rId5"/>
+          <a:srcRect l="3083" t="76719" r="65785" b="-1873"/>
+          <a:stretch>
+            <a:fillRect/>
+          </a:stretch>
+        </p:blipFill>
+        <p:spPr>
+          <a:xfrm>
+            <a:off x="4739907" y="3863304"/>
+            <a:ext cx="2743200" cy="861483"/>
+          </a:xfrm>
+          <a:prstGeom prst="rect">
+            <a:avLst/>
+          </a:prstGeom>
+        </p:spPr>
+      </p:pic>
+      <p:pic>
+        <p:nvPicPr>
+          <p:cNvPr id="22" name="Picture 21">
+            <a:extLst>
+              <a:ext uri="{FF2B5EF4-FFF2-40B4-BE49-F238E27FC236}">
+                <a16:creationId xmlns:a16="http://schemas.microsoft.com/office/drawing/2014/main" id="{F07E5F78-299F-3E21-EA01-CDFB361241F5}"/>
+              </a:ext>
+            </a:extLst>
+          </p:cNvPr>
+          <p:cNvPicPr>
+            <a:picLocks noChangeAspect="1"/>
+          </p:cNvPicPr>
+          <p:nvPr/>
+        </p:nvPicPr>
+        <p:blipFill>
+          <a:blip r:embed="rId5"/>
+          <a:srcRect l="76720" b="83081"/>
+          <a:stretch>
+            <a:fillRect/>
+          </a:stretch>
+        </p:blipFill>
+        <p:spPr>
+          <a:xfrm>
+            <a:off x="4754880" y="4830233"/>
+            <a:ext cx="2713254" cy="601557"/>
           </a:xfrm>
           <a:prstGeom prst="rect">
             <a:avLst/>
@@ -6822,7 +6990,7 @@
         <p:spPr>
           <a:xfrm>
             <a:off x="1371600" y="1828800"/>
-            <a:ext cx="9418320" cy="1645920"/>
+            <a:ext cx="10322560" cy="1645920"/>
           </a:xfrm>
           <a:prstGeom prst="roundRect">
             <a:avLst/>
@@ -6912,7 +7080,7 @@
         <p:spPr>
           <a:xfrm>
             <a:off x="1645920" y="2011680"/>
-            <a:ext cx="8961120" cy="1280160"/>
+            <a:ext cx="5711249" cy="995144"/>
           </a:xfrm>
           <a:prstGeom prst="rect">
             <a:avLst/>
@@ -7153,6 +7321,68 @@
           <a:xfrm>
             <a:off x="8717127" y="3847482"/>
             <a:ext cx="1280160" cy="1651948"/>
+          </a:xfrm>
+          <a:prstGeom prst="rect">
+            <a:avLst/>
+          </a:prstGeom>
+        </p:spPr>
+      </p:pic>
+      <p:pic>
+        <p:nvPicPr>
+          <p:cNvPr id="23" name="Picture 22">
+            <a:extLst>
+              <a:ext uri="{FF2B5EF4-FFF2-40B4-BE49-F238E27FC236}">
+                <a16:creationId xmlns:a16="http://schemas.microsoft.com/office/drawing/2014/main" id="{C5D5B4ED-6C6F-6E60-0600-CA68D862D97E}"/>
+              </a:ext>
+            </a:extLst>
+          </p:cNvPr>
+          <p:cNvPicPr>
+            <a:picLocks noChangeAspect="1"/>
+          </p:cNvPicPr>
+          <p:nvPr/>
+        </p:nvPicPr>
+        <p:blipFill>
+          <a:blip r:embed="rId5"/>
+          <a:srcRect l="3083" t="76719" r="65785" b="-1873"/>
+          <a:stretch>
+            <a:fillRect/>
+          </a:stretch>
+        </p:blipFill>
+        <p:spPr>
+          <a:xfrm>
+            <a:off x="7237048" y="2613236"/>
+            <a:ext cx="3095672" cy="861483"/>
+          </a:xfrm>
+          <a:prstGeom prst="rect">
+            <a:avLst/>
+          </a:prstGeom>
+        </p:spPr>
+      </p:pic>
+      <p:pic>
+        <p:nvPicPr>
+          <p:cNvPr id="25" name="Picture 24">
+            <a:extLst>
+              <a:ext uri="{FF2B5EF4-FFF2-40B4-BE49-F238E27FC236}">
+                <a16:creationId xmlns:a16="http://schemas.microsoft.com/office/drawing/2014/main" id="{119F8A59-A6FD-80A0-2348-2EF6B093950A}"/>
+              </a:ext>
+            </a:extLst>
+          </p:cNvPr>
+          <p:cNvPicPr>
+            <a:picLocks noChangeAspect="1"/>
+          </p:cNvPicPr>
+          <p:nvPr/>
+        </p:nvPicPr>
+        <p:blipFill>
+          <a:blip r:embed="rId5"/>
+          <a:srcRect l="76720" b="83081"/>
+          <a:stretch>
+            <a:fillRect/>
+          </a:stretch>
+        </p:blipFill>
+        <p:spPr>
+          <a:xfrm>
+            <a:off x="7237048" y="1907695"/>
+            <a:ext cx="3095672" cy="601557"/>
           </a:xfrm>
           <a:prstGeom prst="rect">
             <a:avLst/>
@@ -8409,7 +8639,7 @@
         <p:spPr>
           <a:xfrm>
             <a:off x="1645920" y="2011680"/>
-            <a:ext cx="8961120" cy="3291840"/>
+            <a:ext cx="8961120" cy="1179810"/>
           </a:xfrm>
           <a:prstGeom prst="rect">
             <a:avLst/>
@@ -8431,6 +8661,7 @@
               </a:defRPr>
             </a:pPr>
             <a:r>
+              <a:rPr dirty="0"/>
               <a:t>Implemented City Planner Features:</a:t>
             </a:r>
           </a:p>
@@ -8447,22 +8678,36 @@
               </a:defRPr>
             </a:pPr>
             <a:r>
+              <a:rPr dirty="0"/>
               <a:t>• Live Repair Queue: Automatically ingests citizen complaints and displays them with AI-assigned severity ratings.</a:t>
             </a:r>
-            <a:br/>
-            <a:r>
-              <a:t>• CapEx Misalignment Matrix: A data table cross-referencing citizen demand volumes against planned municipal budgets.</a:t>
-            </a:r>
-            <a:br/>
-            <a:r>
-              <a:t>• Live Weather Telemetry: Integrated Open-Meteo API to display real-time weather conditions for the jurisdiction.</a:t>
-            </a:r>
-            <a:br/>
-            <a:r>
+            <a:br>
+              <a:rPr dirty="0"/>
+            </a:br>
+            <a:r>
+              <a:rPr dirty="0"/>
+              <a:t>• </a:t>
+            </a:r>
+            <a:r>
+              <a:rPr dirty="0" err="1"/>
+              <a:t>CapEx</a:t>
+            </a:r>
+            <a:r>
+              <a:rPr dirty="0"/>
+              <a:t> Misalignment Matrix: A data table cross-referencing citizen demand volumes against planned municipal budgets.</a:t>
+            </a:r>
+            <a:br>
+              <a:rPr dirty="0"/>
+            </a:br>
+            <a:r>
+              <a:rPr dirty="0"/>
               <a:t>• GIS Map Integration: Leaflet.js map integration for plotting incident coordinates.</a:t>
             </a:r>
-            <a:br/>
-            <a:r>
+            <a:br>
+              <a:rPr dirty="0"/>
+            </a:br>
+            <a:r>
+              <a:rPr dirty="0"/>
               <a:t>• Node Federation: Ability to toggle perspectives between different BRICS nations (India, Brazil, SA).</a:t>
             </a:r>
           </a:p>
@@ -8665,8 +8910,8 @@
         </p:nvSpPr>
         <p:spPr>
           <a:xfrm>
-            <a:off x="2565400" y="1623060"/>
-            <a:ext cx="7010400" cy="4617720"/>
+            <a:off x="2245360" y="1371600"/>
+            <a:ext cx="7620000" cy="5120640"/>
           </a:xfrm>
           <a:prstGeom prst="roundRect">
             <a:avLst/>
@@ -8930,8 +9175,8 @@
         </p:nvSpPr>
         <p:spPr>
           <a:xfrm>
-            <a:off x="2531532" y="1623060"/>
-            <a:ext cx="7103535" cy="4498340"/>
+            <a:off x="2346960" y="1371600"/>
+            <a:ext cx="7579360" cy="5029200"/>
           </a:xfrm>
           <a:prstGeom prst="roundRect">
             <a:avLst/>

</xml_diff>